<commit_message>
feat: expand C27 to ten labs with Pareto and dashboard skills
</commit_message>
<xml_diff>
--- a/labs/lab-01-excel-to-word/data/templates/Northstar_Management_Deck_Template.pptx
+++ b/labs/lab-01-excel-to-word/data/templates/Northstar_Management_Deck_Template.pptx
@@ -4097,7 +4097,7 @@
               <a:defRPr sz="1000"/>
             </a:pPr>
             <a:r>
-              <a:t>C27 v2.1 | Synthetic Northstar example | 2026-09-30 | All filters All | Slide1</a:t>
+              <a:t>C27 v2.2 | Synthetic Northstar example | 2026-09-30 | All filters All | Slide1</a:t>
             </a:r>
           </a:p>
         </p:txBody>
@@ -4212,7 +4212,7 @@
               <a:defRPr sz="1000"/>
             </a:pPr>
             <a:r>
-              <a:t>C27 v2.1 | Synthetic Northstar example | 2026-09-30 | All filters All | Slide2</a:t>
+              <a:t>C27 v2.2 | Synthetic Northstar example | 2026-09-30 | All filters All | Slide2</a:t>
             </a:r>
           </a:p>
         </p:txBody>
@@ -4327,7 +4327,7 @@
               <a:defRPr sz="1000"/>
             </a:pPr>
             <a:r>
-              <a:t>C27 v2.1 | Synthetic Northstar example | 2026-09-30 | All filters All | Slide3</a:t>
+              <a:t>C27 v2.2 | Synthetic Northstar example | 2026-09-30 | All filters All | Slide3</a:t>
             </a:r>
           </a:p>
         </p:txBody>
@@ -4442,7 +4442,7 @@
               <a:defRPr sz="1000"/>
             </a:pPr>
             <a:r>
-              <a:t>C27 v2.1 | Synthetic Northstar example | 2026-09-30 | All filters All | Slide4</a:t>
+              <a:t>C27 v2.2 | Synthetic Northstar example | 2026-09-30 | All filters All | Slide4</a:t>
             </a:r>
           </a:p>
         </p:txBody>
@@ -4557,7 +4557,7 @@
               <a:defRPr sz="1000"/>
             </a:pPr>
             <a:r>
-              <a:t>C27 v2.1 | Synthetic Northstar example | 2026-09-30 | All filters All | Slide5</a:t>
+              <a:t>C27 v2.2 | Synthetic Northstar example | 2026-09-30 | All filters All | Slide5</a:t>
             </a:r>
           </a:p>
         </p:txBody>
@@ -4672,7 +4672,7 @@
               <a:defRPr sz="1000"/>
             </a:pPr>
             <a:r>
-              <a:t>C27 v2.1 | Synthetic Northstar example | 2026-09-30 | All filters All | Slide6</a:t>
+              <a:t>C27 v2.2 | Synthetic Northstar example | 2026-09-30 | All filters All | Slide6</a:t>
             </a:r>
           </a:p>
         </p:txBody>
@@ -4787,7 +4787,7 @@
               <a:defRPr sz="1000"/>
             </a:pPr>
             <a:r>
-              <a:t>C27 v2.1 | Synthetic Northstar example | 2026-09-30 | All filters All | Slide7</a:t>
+              <a:t>C27 v2.2 | Synthetic Northstar example | 2026-09-30 | All filters All | Slide7</a:t>
             </a:r>
           </a:p>
         </p:txBody>
@@ -4902,7 +4902,7 @@
               <a:defRPr sz="1000"/>
             </a:pPr>
             <a:r>
-              <a:t>C27 v2.1 | Synthetic Northstar example | 2026-09-30 | All filters All | Slide8</a:t>
+              <a:t>C27 v2.2 | Synthetic Northstar example | 2026-09-30 | All filters All | Slide8</a:t>
             </a:r>
           </a:p>
         </p:txBody>

</xml_diff>